<commit_message>
updated team 6 toyota hybrid presentation
</commit_message>
<xml_diff>
--- a/Presentation/Team6_Toyota_Hybrid_Presentation.pptx
+++ b/Presentation/Team6_Toyota_Hybrid_Presentation.pptx
@@ -1514,18 +1514,7 @@
                 <a:ea typeface="Cambria" pitchFamily="34" charset="-122"/>
                 <a:cs typeface="Cambria" pitchFamily="34" charset="-120"/>
               </a:rPr>
-              <a:t>Hybrid vs. Other </a:t>
-            </a:r>
-            <a:r>
-              <a:rPr lang="en-US" sz="4000" b="1">
-                <a:solidFill>
-                  <a:srgbClr val="FFFFFF"/>
-                </a:solidFill>
-                <a:latin typeface="Cambria" pitchFamily="34" charset="0"/>
-                <a:ea typeface="Cambria" pitchFamily="34" charset="-122"/>
-                <a:cs typeface="Cambria" pitchFamily="34" charset="-120"/>
-              </a:rPr>
-              <a:t>Fuel Types</a:t>
+              <a:t>Hybrid vs. Other Fuel Types</a:t>
             </a:r>
             <a:endParaRPr lang="en-US" sz="4000" dirty="0"/>
           </a:p>
@@ -1715,6 +1704,45 @@
               <a:t>Date: July 2026</a:t>
             </a:r>
             <a:endParaRPr lang="en-US" sz="1200" dirty="0"/>
+          </a:p>
+        </p:txBody>
+      </p:sp>
+      <p:sp>
+        <p:nvSpPr>
+          <p:cNvPr id="9" name="TextBox 8">
+            <a:extLst>
+              <a:ext uri="{FF2B5EF4-FFF2-40B4-BE49-F238E27FC236}">
+                <a16:creationId xmlns:a16="http://schemas.microsoft.com/office/drawing/2014/main" id="{C1EEBC51-C427-74B0-A0B2-4D5D65FA280D}"/>
+              </a:ext>
+            </a:extLst>
+          </p:cNvPr>
+          <p:cNvSpPr txBox="1"/>
+          <p:nvPr/>
+        </p:nvSpPr>
+        <p:spPr>
+          <a:xfrm>
+            <a:off x="853440" y="1554480"/>
+            <a:ext cx="5557547" cy="646331"/>
+          </a:xfrm>
+          <a:prstGeom prst="rect">
+            <a:avLst/>
+          </a:prstGeom>
+          <a:noFill/>
+        </p:spPr>
+        <p:txBody>
+          <a:bodyPr wrap="none" rtlCol="0">
+            <a:spAutoFit/>
+          </a:bodyPr>
+          <a:lstStyle/>
+          <a:p>
+            <a:r>
+              <a:rPr lang="en-US" sz="3600" dirty="0">
+                <a:solidFill>
+                  <a:schemeClr val="bg1"/>
+                </a:solidFill>
+              </a:rPr>
+              <a:t>Project Pretention by team 6</a:t>
+            </a:r>
           </a:p>
         </p:txBody>
       </p:sp>

</xml_diff>